<commit_message>
Add teammate algorithm comparison
</commit_message>
<xml_diff>
--- a/deliverables/DBTable_Final_Project_Presentation.pptx
+++ b/deliverables/DBTable_Final_Project_Presentation.pptx
@@ -1198,7 +1198,7 @@
                 <a:latin typeface="Microsoft JhengHei"/>
                 <a:ea typeface="Microsoft JhengHei"/>
               </a:rPr>
-              <a:t>與組員演算法比較時，用同一組核心指標</a:t>
+              <a:t>比較結果：HybridTSS 查詢最快，CutSplit 最省記憶體</a:t>
             </a:r>
           </a:p>
         </p:txBody>
@@ -1239,7 +1239,7 @@
                 <a:latin typeface="Microsoft JhengHei"/>
                 <a:ea typeface="Microsoft JhengHei"/>
               </a:rPr>
-              <a:t>Dimension</a:t>
+              <a:t>Metric</a:t>
             </a:r>
           </a:p>
         </p:txBody>
@@ -1321,7 +1321,7 @@
                 <a:latin typeface="Microsoft JhengHei"/>
                 <a:ea typeface="Microsoft JhengHei"/>
               </a:rPr>
-              <a:t>Group Algorithm A</a:t>
+              <a:t>HybridTSS</a:t>
             </a:r>
           </a:p>
         </p:txBody>
@@ -1362,7 +1362,7 @@
                 <a:latin typeface="Microsoft JhengHei"/>
                 <a:ea typeface="Microsoft JhengHei"/>
               </a:rPr>
-              <a:t>Group Algorithm B</a:t>
+              <a:t>CutSplit</a:t>
             </a:r>
           </a:p>
         </p:txBody>
@@ -1485,7 +1485,7 @@
                 <a:latin typeface="Microsoft JhengHei"/>
                 <a:ea typeface="Microsoft JhengHei"/>
               </a:rPr>
-              <a:t>replace</a:t>
+              <a:t>0.0249 s</a:t>
             </a:r>
           </a:p>
         </p:txBody>
@@ -1526,7 +1526,7 @@
                 <a:latin typeface="Microsoft JhengHei"/>
                 <a:ea typeface="Microsoft JhengHei"/>
               </a:rPr>
-              <a:t>replace</a:t>
+              <a:t>0.4625 s</a:t>
             </a:r>
           </a:p>
         </p:txBody>
@@ -1567,7 +1567,7 @@
                 <a:latin typeface="Microsoft JhengHei"/>
                 <a:ea typeface="Microsoft JhengHei"/>
               </a:rPr>
-              <a:t>Lookup</a:t>
+              <a:t>Avg lookup</a:t>
             </a:r>
           </a:p>
         </p:txBody>
@@ -1608,7 +1608,7 @@
                 <a:latin typeface="Microsoft JhengHei"/>
                 <a:ea typeface="Microsoft JhengHei"/>
               </a:rPr>
-              <a:t>9781 ns avg</a:t>
+              <a:t>9781 ns</a:t>
             </a:r>
           </a:p>
         </p:txBody>
@@ -1649,7 +1649,7 @@
                 <a:latin typeface="Microsoft JhengHei"/>
                 <a:ea typeface="Microsoft JhengHei"/>
               </a:rPr>
-              <a:t>replace</a:t>
+              <a:t>133.987 ns</a:t>
             </a:r>
           </a:p>
         </p:txBody>
@@ -1690,7 +1690,7 @@
                 <a:latin typeface="Microsoft JhengHei"/>
                 <a:ea typeface="Microsoft JhengHei"/>
               </a:rPr>
-              <a:t>replace</a:t>
+              <a:t>300.719 ns</a:t>
             </a:r>
           </a:p>
         </p:txBody>
@@ -1813,7 +1813,7 @@
                 <a:latin typeface="Microsoft JhengHei"/>
                 <a:ea typeface="Microsoft JhengHei"/>
               </a:rPr>
-              <a:t>replace</a:t>
+              <a:t>709.45 MiB</a:t>
             </a:r>
           </a:p>
         </p:txBody>
@@ -1854,7 +1854,7 @@
                 <a:latin typeface="Microsoft JhengHei"/>
                 <a:ea typeface="Microsoft JhengHei"/>
               </a:rPr>
-              <a:t>replace</a:t>
+              <a:t>0.512 MiB</a:t>
             </a:r>
           </a:p>
         </p:txBody>
@@ -1895,7 +1895,7 @@
                 <a:latin typeface="Microsoft JhengHei"/>
                 <a:ea typeface="Microsoft JhengHei"/>
               </a:rPr>
-              <a:t>Best fit</a:t>
+              <a:t>Takeaway</a:t>
             </a:r>
           </a:p>
         </p:txBody>
@@ -1936,7 +1936,7 @@
                 <a:latin typeface="Microsoft JhengHei"/>
                 <a:ea typeface="Microsoft JhengHei"/>
               </a:rPr>
-              <a:t>IP bits are discriminative</a:t>
+              <a:t>method demo</a:t>
             </a:r>
           </a:p>
         </p:txBody>
@@ -1977,7 +1977,7 @@
                 <a:latin typeface="Microsoft JhengHei"/>
                 <a:ea typeface="Microsoft JhengHei"/>
               </a:rPr>
-              <a:t>replace</a:t>
+              <a:t>fastest lookup</a:t>
             </a:r>
           </a:p>
         </p:txBody>
@@ -2018,7 +2018,7 @@
                 <a:latin typeface="Microsoft JhengHei"/>
                 <a:ea typeface="Microsoft JhengHei"/>
               </a:rPr>
-              <a:t>replace</a:t>
+              <a:t>best balance</a:t>
             </a:r>
           </a:p>
         </p:txBody>
@@ -2031,15 +2031,19 @@
         </p:nvSpPr>
         <p:spPr>
           <a:xfrm>
-            <a:off x="822960" y="5303520"/>
-            <a:ext cx="10058400" cy="274320"/>
-          </a:xfrm>
-          <a:prstGeom prst="roundRect">
-            <a:avLst/>
-          </a:prstGeom>
-          <a:noFill/>
-          <a:ln>
-            <a:noFill/>
+            <a:off x="777240" y="5074920"/>
+            <a:ext cx="10515600" cy="621792"/>
+          </a:xfrm>
+          <a:prstGeom prst="roundRect">
+            <a:avLst/>
+          </a:prstGeom>
+          <a:solidFill>
+            <a:srgbClr val="FFFFFF"/>
+          </a:solidFill>
+          <a:ln w="9525">
+            <a:solidFill>
+              <a:srgbClr val="D6DEE7"/>
+            </a:solidFill>
           </a:ln>
         </p:spPr>
         <p:txBody>
@@ -2055,7 +2059,7 @@
                 <a:latin typeface="Microsoft JhengHei"/>
                 <a:ea typeface="Microsoft JhengHei"/>
               </a:rPr>
-              <a:t>取得同組兩位同學的演算法與實測數據後，替換 Algorithm A/B 欄位即可。</a:t>
+              <a:t>注意：DBTable 是本專案 Python 教學版，絕對數字會受實作語言與最佳化程度影響。就本次實測而言，HybridTSS lookup 最快；CutSplit 在 build、lookup、memory 三者最均衡。</a:t>
             </a:r>
           </a:p>
         </p:txBody>

</xml_diff>

<commit_message>
Run TA DBTable benchmark
</commit_message>
<xml_diff>
--- a/deliverables/DBTable_Final_Project_Presentation.pptx
+++ b/deliverables/DBTable_Final_Project_Presentation.pptx
@@ -317,7 +317,7 @@
                 <a:latin typeface="Microsoft JhengHei"/>
                 <a:ea typeface="Microsoft JhengHei"/>
               </a:rPr>
-              <a:t>9781 ns</a:t>
+              <a:t>60 ns</a:t>
             </a:r>
           </a:p>
         </p:txBody>
@@ -399,7 +399,7 @@
                 <a:latin typeface="Microsoft JhengHei"/>
                 <a:ea typeface="Microsoft JhengHei"/>
               </a:rPr>
-              <a:t>20.55 MiB</a:t>
+              <a:t>4.02 MiB</a:t>
             </a:r>
           </a:p>
         </p:txBody>
@@ -683,7 +683,7 @@
                 <a:latin typeface="Microsoft JhengHei"/>
                 <a:ea typeface="Microsoft JhengHei"/>
               </a:rPr>
-              <a:t>1.553 s</a:t>
+              <a:t>0.378 s</a:t>
             </a:r>
           </a:p>
         </p:txBody>
@@ -765,7 +765,7 @@
                 <a:latin typeface="Microsoft JhengHei"/>
                 <a:ea typeface="Microsoft JhengHei"/>
               </a:rPr>
-              <a:t>9781 ns</a:t>
+              <a:t>60 ns</a:t>
             </a:r>
           </a:p>
         </p:txBody>
@@ -847,7 +847,7 @@
                 <a:latin typeface="Microsoft JhengHei"/>
                 <a:ea typeface="Microsoft JhengHei"/>
               </a:rPr>
-              <a:t>35100 ns</a:t>
+              <a:t>53 ns</a:t>
             </a:r>
           </a:p>
         </p:txBody>
@@ -888,7 +888,7 @@
                 <a:latin typeface="Microsoft JhengHei"/>
                 <a:ea typeface="Microsoft JhengHei"/>
               </a:rPr>
-              <a:t>P99 lookup</a:t>
+              <a:t>min avg lookup</a:t>
             </a:r>
           </a:p>
         </p:txBody>
@@ -929,7 +929,7 @@
                 <a:latin typeface="Microsoft JhengHei"/>
                 <a:ea typeface="Microsoft JhengHei"/>
               </a:rPr>
-              <a:t>20.55 MiB</a:t>
+              <a:t>4.02 MiB</a:t>
             </a:r>
           </a:p>
         </p:txBody>
@@ -1198,7 +1198,7 @@
                 <a:latin typeface="Microsoft JhengHei"/>
                 <a:ea typeface="Microsoft JhengHei"/>
               </a:rPr>
-              <a:t>比較結果：HybridTSS 查詢最快，CutSplit 最省記憶體</a:t>
+              <a:t>比較結果：DBTable 查詢最快，CutSplit 最省記憶體</a:t>
             </a:r>
           </a:p>
         </p:txBody>
@@ -1444,7 +1444,7 @@
                 <a:latin typeface="Microsoft JhengHei"/>
                 <a:ea typeface="Microsoft JhengHei"/>
               </a:rPr>
-              <a:t>1.553 s</a:t>
+              <a:t>0.378 s</a:t>
             </a:r>
           </a:p>
         </p:txBody>
@@ -1608,7 +1608,7 @@
                 <a:latin typeface="Microsoft JhengHei"/>
                 <a:ea typeface="Microsoft JhengHei"/>
               </a:rPr>
-              <a:t>9781 ns</a:t>
+              <a:t>60 ns</a:t>
             </a:r>
           </a:p>
         </p:txBody>
@@ -1772,7 +1772,7 @@
                 <a:latin typeface="Microsoft JhengHei"/>
                 <a:ea typeface="Microsoft JhengHei"/>
               </a:rPr>
-              <a:t>20.55 MiB</a:t>
+              <a:t>4.017 MiB</a:t>
             </a:r>
           </a:p>
         </p:txBody>
@@ -1936,7 +1936,7 @@
                 <a:latin typeface="Microsoft JhengHei"/>
                 <a:ea typeface="Microsoft JhengHei"/>
               </a:rPr>
-              <a:t>method demo</a:t>
+              <a:t>fastest lookup</a:t>
             </a:r>
           </a:p>
         </p:txBody>
@@ -1977,7 +1977,7 @@
                 <a:latin typeface="Microsoft JhengHei"/>
                 <a:ea typeface="Microsoft JhengHei"/>
               </a:rPr>
-              <a:t>fastest lookup</a:t>
+              <a:t>fastest build</a:t>
             </a:r>
           </a:p>
         </p:txBody>
@@ -2018,7 +2018,7 @@
                 <a:latin typeface="Microsoft JhengHei"/>
                 <a:ea typeface="Microsoft JhengHei"/>
               </a:rPr>
-              <a:t>best balance</a:t>
+              <a:t>lowest memory</a:t>
             </a:r>
           </a:p>
         </p:txBody>
@@ -2059,7 +2059,7 @@
                 <a:latin typeface="Microsoft JhengHei"/>
                 <a:ea typeface="Microsoft JhengHei"/>
               </a:rPr>
-              <a:t>注意：DBTable 是本專案 Python 教學版，絕對數字會受實作語言與最佳化程度影響。就本次實測而言，HybridTSS lookup 最快；CutSplit 在 build、lookup、memory 三者最均衡。</a:t>
+              <a:t>更新後 DBTable 使用 AMPS/助教 C++ 實作重跑：lookup avg 約 56.776 ns，是三者中最快；CutSplit 記憶體最低；HybridTSS 建表最快但記憶體最高。</a:t>
             </a:r>
           </a:p>
         </p:txBody>
@@ -5351,7 +5351,7 @@
                 <a:latin typeface="Microsoft JhengHei"/>
                 <a:ea typeface="Microsoft JhengHei"/>
               </a:rPr>
-              <a:t>本專案實作：保留核心概念，讓實驗可重現</a:t>
+              <a:t>本專案實作：使用 AMPS/助教 C++ DBTable.cpp 實測</a:t>
             </a:r>
           </a:p>
         </p:txBody>
@@ -5474,7 +5474,7 @@
                 <a:latin typeface="Microsoft JhengHei"/>
                 <a:ea typeface="Microsoft JhengHei"/>
               </a:rPr>
-              <a:t>src/classbench.py</a:t>
+              <a:t>external/amps/src/DBTable.cpp</a:t>
             </a:r>
           </a:p>
         </p:txBody>
@@ -5515,7 +5515,7 @@
                 <a:latin typeface="Microsoft JhengHei"/>
                 <a:ea typeface="Microsoft JhengHei"/>
               </a:rPr>
-              <a:t>解析 ClassBench rules/trace，做 exact five-tuple match。</a:t>
+              <a:t>AMPS/助教 DBTable C++ 實作來源。</a:t>
             </a:r>
           </a:p>
         </p:txBody>
@@ -5556,7 +5556,7 @@
                 <a:latin typeface="Microsoft JhengHei"/>
                 <a:ea typeface="Microsoft JhengHei"/>
               </a:rPr>
-              <a:t>src/dbtable_classifier.py</a:t>
+              <a:t>cpp/benchmark_ta_dbtable.cpp</a:t>
             </a:r>
           </a:p>
         </p:txBody>
@@ -5597,7 +5597,7 @@
                 <a:latin typeface="Microsoft JhengHei"/>
                 <a:ea typeface="Microsoft JhengHei"/>
               </a:rPr>
-              <a:t>選 discriminative bits，建立 bucket table，執行 lookup。</a:t>
+              <a:t>ClassBench parser + DBT::DBTable benchmark harness。</a:t>
             </a:r>
           </a:p>
         </p:txBody>
@@ -5638,7 +5638,7 @@
                 <a:latin typeface="Microsoft JhengHei"/>
                 <a:ea typeface="Microsoft JhengHei"/>
               </a:rPr>
-              <a:t>scripts/run_experiment.py</a:t>
+              <a:t>scripts/run_ta_dbtable_experiment.py</a:t>
             </a:r>
           </a:p>
         </p:txBody>
@@ -5679,7 +5679,7 @@
                 <a:latin typeface="Microsoft JhengHei"/>
                 <a:ea typeface="Microsoft JhengHei"/>
               </a:rPr>
-              <a:t>量測 build time、lookup time、memory consumption。</a:t>
+              <a:t>自動編譯並跑 5 次，輸出正式數據。</a:t>
             </a:r>
           </a:p>
         </p:txBody>
@@ -5720,7 +5720,7 @@
                 <a:latin typeface="Microsoft JhengHei"/>
                 <a:ea typeface="Microsoft JhengHei"/>
               </a:rPr>
-              <a:t>scripts/validate_correctness.py</a:t>
+              <a:t>results/ta_dbtable_results.json</a:t>
             </a:r>
           </a:p>
         </p:txBody>
@@ -5761,7 +5761,7 @@
                 <a:latin typeface="Microsoft JhengHei"/>
                 <a:ea typeface="Microsoft JhengHei"/>
               </a:rPr>
-              <a:t>用線性掃描 oracle 做抽樣正確性驗證。</a:t>
+              <a:t>正式 build/lookup/memory 結果。</a:t>
             </a:r>
           </a:p>
         </p:txBody>
@@ -5774,8 +5774,8 @@
         </p:nvSpPr>
         <p:spPr>
           <a:xfrm>
-            <a:off x="868680" y="5166360"/>
-            <a:ext cx="10241280" cy="320040"/>
+            <a:off x="868680" y="5074920"/>
+            <a:ext cx="10241280" cy="438912"/>
           </a:xfrm>
           <a:prstGeom prst="roundRect">
             <a:avLst/>
@@ -5791,14 +5791,14 @@
           <a:p>
             <a:pPr algn="l"/>
             <a:r>
-              <a:rPr lang="zh-TW" sz="1400" b="1">
+              <a:rPr lang="zh-TW" sz="1300" b="1">
                 <a:solidFill>
                   <a:srgbClr val="A23B3B"/>
                 </a:solidFill>
                 <a:latin typeface="Microsoft JhengHei"/>
                 <a:ea typeface="Microsoft JhengHei"/>
               </a:rPr>
-              <a:t>限制：這是 DBTable-inspired 教學實作，不是 AMPS C++ DBTable 的完整逐行移植。</a:t>
+              <a:t>註：Downloads 的助教檔保留於 ta_reference/；實測使用 AMPS 官方 src/DBTable.cpp，避免本地複製檔中 Init 行被註解吃掉的問題。</a:t>
             </a:r>
           </a:p>
         </p:txBody>
@@ -6168,7 +6168,7 @@
                 <a:latin typeface="Microsoft JhengHei"/>
                 <a:ea typeface="Microsoft JhengHei"/>
               </a:rPr>
-              <a:t>4,096</a:t>
+              <a:t>4</a:t>
             </a:r>
           </a:p>
         </p:txBody>
@@ -6209,7 +6209,7 @@
                 <a:latin typeface="Microsoft JhengHei"/>
                 <a:ea typeface="Microsoft JhengHei"/>
               </a:rPr>
-              <a:t>buckets</a:t>
+              <a:t>DBT BINTH</a:t>
             </a:r>
           </a:p>
         </p:txBody>
@@ -6250,7 +6250,7 @@
                 <a:latin typeface="Microsoft JhengHei"/>
                 <a:ea typeface="Microsoft JhengHei"/>
               </a:rPr>
-              <a:t>169.3</a:t>
+              <a:t>5</a:t>
             </a:r>
           </a:p>
         </p:txBody>
@@ -6291,7 +6291,7 @@
                 <a:latin typeface="Microsoft JhengHei"/>
                 <a:ea typeface="Microsoft JhengHei"/>
               </a:rPr>
-              <a:t>avg bucket size</a:t>
+              <a:t>benchmark repeats</a:t>
             </a:r>
           </a:p>
         </p:txBody>

</xml_diff>

<commit_message>
Update CutSplit comparison metrics
</commit_message>
<xml_diff>
--- a/deliverables/DBTable_Final_Project_Presentation.pptx
+++ b/deliverables/DBTable_Final_Project_Presentation.pptx
@@ -1198,7 +1198,7 @@
                 <a:latin typeface="Microsoft JhengHei"/>
                 <a:ea typeface="Microsoft JhengHei"/>
               </a:rPr>
-              <a:t>比較結果：DBTable 查詢最快，CutSplit 最省記憶體</a:t>
+              <a:t>比較結果：DBTable 查詢最快且記憶體最低</a:t>
             </a:r>
           </a:p>
         </p:txBody>
@@ -1526,7 +1526,7 @@
                 <a:latin typeface="Microsoft JhengHei"/>
                 <a:ea typeface="Microsoft JhengHei"/>
               </a:rPr>
-              <a:t>0.4625 s</a:t>
+              <a:t>0.424338 s</a:t>
             </a:r>
           </a:p>
         </p:txBody>
@@ -1690,7 +1690,7 @@
                 <a:latin typeface="Microsoft JhengHei"/>
                 <a:ea typeface="Microsoft JhengHei"/>
               </a:rPr>
-              <a:t>300.719 ns</a:t>
+              <a:t>285.687 ns</a:t>
             </a:r>
           </a:p>
         </p:txBody>
@@ -1854,7 +1854,7 @@
                 <a:latin typeface="Microsoft JhengHei"/>
                 <a:ea typeface="Microsoft JhengHei"/>
               </a:rPr>
-              <a:t>0.512 MiB</a:t>
+              <a:t>537.38 MiB</a:t>
             </a:r>
           </a:p>
         </p:txBody>
@@ -1936,7 +1936,7 @@
                 <a:latin typeface="Microsoft JhengHei"/>
                 <a:ea typeface="Microsoft JhengHei"/>
               </a:rPr>
-              <a:t>fastest lookup</a:t>
+              <a:t>fastest lookup / lowest memory</a:t>
             </a:r>
           </a:p>
         </p:txBody>
@@ -2018,7 +2018,7 @@
                 <a:latin typeface="Microsoft JhengHei"/>
                 <a:ea typeface="Microsoft JhengHei"/>
               </a:rPr>
-              <a:t>lowest memory</a:t>
+              <a:t>shorter build than DBTable</a:t>
             </a:r>
           </a:p>
         </p:txBody>
@@ -2059,7 +2059,7 @@
                 <a:latin typeface="Microsoft JhengHei"/>
                 <a:ea typeface="Microsoft JhengHei"/>
               </a:rPr>
-              <a:t>更新後 DBTable 使用 AMPS/助教 C++ 實作重跑：lookup avg 約 56.776 ns，是三者中最快；CutSplit 記憶體最低；HybridTSS 建表最快但記憶體最高。</a:t>
+              <a:t>更新後 DBTable 使用 AMPS/助教 C++ 實作重跑：lookup avg 約 59.902 ns，是三者中最快，memory 約 4.017 MiB 也是三者最低；HybridTSS 建表最快但記憶體最高。</a:t>
             </a:r>
           </a:p>
         </p:txBody>

</xml_diff>